<commit_message>
``` docs(outputs): 更新App Description FitPulse演示文稿
- 替换了App_Description_FitPulse_filled.pptx文件
- 包含最新的应用描述内容更新
```
</commit_message>
<xml_diff>
--- a/docs/outputs/App_Description_FitPulse_filled.pptx
+++ b/docs/outputs/App_Description_FitPulse_filled.pptx
@@ -894,8 +894,8 @@
         </p:nvSpPr>
         <p:spPr>
           <a:xfrm>
-            <a:off x="1143225" y="685800"/>
-            <a:ext cx="4572225" cy="3429000"/>
+            <a:off x="1143000" y="685800"/>
+            <a:ext cx="4572000" cy="3429000"/>
           </a:xfrm>
           <a:custGeom>
             <a:avLst/>
@@ -1957,8 +1957,8 @@
         </p:nvSpPr>
         <p:spPr>
           <a:xfrm>
-            <a:off x="1143225" y="685800"/>
-            <a:ext cx="4572225" cy="3429000"/>
+            <a:off x="1143000" y="685800"/>
+            <a:ext cx="4572000" cy="3429000"/>
           </a:xfrm>
           <a:custGeom>
             <a:avLst/>
@@ -15380,30 +15380,6 @@
           </a:p>
         </p:txBody>
       </p:sp>
-      <p:pic>
-        <p:nvPicPr>
-          <p:cNvPr id="195" name="Picture 194" descr="11-menu-function-collage.jpg"/>
-          <p:cNvPicPr>
-            <a:picLocks noChangeAspect="1"/>
-          </p:cNvPicPr>
-          <p:nvPr/>
-        </p:nvPicPr>
-        <p:blipFill>
-          <a:blip r:embed="rId3"/>
-          <a:stretch>
-            <a:fillRect/>
-          </a:stretch>
-        </p:blipFill>
-        <p:spPr>
-          <a:xfrm>
-            <a:off x="467544" y="2471236"/>
-            <a:ext cx="8064896" cy="3672408"/>
-          </a:xfrm>
-          <a:prstGeom prst="rect">
-            <a:avLst/>
-          </a:prstGeom>
-        </p:spPr>
-      </p:pic>
     </p:spTree>
   </p:cSld>
   <p:clrMapOvr>
@@ -19452,30 +19428,6 @@
           </a:p>
         </p:txBody>
       </p:sp>
-      <p:pic>
-        <p:nvPicPr>
-          <p:cNvPr id="188" name="Picture 187" descr="10-usage-scenario-collage.jpg"/>
-          <p:cNvPicPr>
-            <a:picLocks noChangeAspect="1"/>
-          </p:cNvPicPr>
-          <p:nvPr/>
-        </p:nvPicPr>
-        <p:blipFill>
-          <a:blip r:embed="rId3"/>
-          <a:stretch>
-            <a:fillRect/>
-          </a:stretch>
-        </p:blipFill>
-        <p:spPr>
-          <a:xfrm>
-            <a:off x="1056427" y="2928934"/>
-            <a:ext cx="6873159" cy="3929066"/>
-          </a:xfrm>
-          <a:prstGeom prst="rect">
-            <a:avLst/>
-          </a:prstGeom>
-        </p:spPr>
-      </p:pic>
     </p:spTree>
   </p:cSld>
   <p:clrMapOvr>

</xml_diff>